<commit_message>
Ajout des noms du groupe au README et au support de soutenance
</commit_message>
<xml_diff>
--- a/soutenance/soutenance.pptx
+++ b/soutenance/soutenance.pptx
@@ -3265,8 +3265,8 @@
         </p:nvSpPr>
         <p:spPr>
           <a:xfrm>
-            <a:off x="731520" y="5669280"/>
-            <a:ext cx="10058400" cy="365760"/>
+            <a:off x="731520" y="5394960"/>
+            <a:ext cx="10515600" cy="822960"/>
           </a:xfrm>
           <a:prstGeom prst="rect">
             <a:avLst/>
@@ -3287,7 +3287,19 @@
                 </a:solidFill>
                 <a:latin typeface="Calibri"/>
               </a:rPr>
-              <a:t>Amir Drabo · Dr TIEMTORE Souleymane · octobre 2026</a:t>
+              <a:t>Groupe : Muhammed Ramadane KOMI · Amir DRABO · Mohamed KABORE</a:t>
+            </a:r>
+          </a:p>
+          <a:p>
+            <a:pPr algn="l"/>
+            <a:r>
+              <a:rPr sz="1400" b="0">
+                <a:solidFill>
+                  <a:srgbClr val="9FC3E6"/>
+                </a:solidFill>
+                <a:latin typeface="Calibri"/>
+              </a:rPr>
+              <a:t>Enseignant : Dr TIEMTORE Souleymane · octobre 2026</a:t>
             </a:r>
           </a:p>
         </p:txBody>

</xml_diff>